<commit_message>
Add Access intro script with exact slide mapping; align speaker notes for slides 9/10
Co-Authored-By: Claude Sonnet 5.5 <noreply@anthropic.com>
Claude-Session: https://claude.ai/code/session_0139kriXJ67p3UvpR2gsSR9G
</commit_message>
<xml_diff>
--- a/videoslides/cleverbox-access-einstieg-slides.pptx
+++ b/videoslides/cleverbox-access-einstieg-slides.pptx
@@ -600,7 +600,7 @@
           <a:p>
             <a:r>
               <a:rPr lang="en-US" dirty="0"/>
-              <a:t>Folie 10 – Skript: Die Buchnummer bekommt den Typ AutoWert. Access zählt dann von selbst hoch: 1, 2, 3 und so weiter. Sie wird unser Primärschlüssel.</a:t>
+              <a:t>Folie 10 – Skript: Access zählt dann von selbst hoch: 1, 2, 3 und so weiter. Sie wird unser Primärschlüssel.</a:t>
             </a:r>
             <a:endParaRPr lang="en-US" dirty="0"/>
           </a:p>
@@ -1392,7 +1392,7 @@
           <a:p>
             <a:r>
               <a:rPr lang="en-US" dirty="0"/>
-              <a:t>Folie 9 – Skript: Jetzt legen wir für jedes Feld den Datentyp fest, denn das haben wir im letzten Video gelernt: Die Buchnummer bekommt den Typ AutoWert. Titel und Autor sind Kurzer Text. Erscheinungsjahr und Seiten sind Zahl. Der Preis ist Währung. Die Bewertung ist ebenfalls Zahl. Ausgeliehen ist Ja/Nein. Das Rückgabedatum ist Datum/Uhrzeit.</a:t>
+              <a:t>Folie 9 – Skript: Jetzt legen wir für jedes Feld den Datentyp fest, denn das haben wir im letzten Video gelernt: Die Buchnummer bekommt den Typ AutoWert. [Dann Folie 10; danach zurück zu Folie 9:] Titel und Autor sind Kurzer Text. Erscheinungsjahr und Seiten sind Zahl. Der Preis ist Währung. Die Bewertung ist ebenfalls Zahl. Ausgeliehen ist Ja/Nein. Das Rückgabedatum ist Datum/Uhrzeit.</a:t>
             </a:r>
             <a:endParaRPr lang="en-US" dirty="0"/>
           </a:p>

</xml_diff>

<commit_message>
Access intro: add transition slide 12 (Plan -> Datenbank -> Tabelle)
Co-Authored-By: Claude Sonnet 5.5 <noreply@anthropic.com>
Claude-Session: https://claude.ai/code/session_0139kriXJ67p3UvpR2gsSR9G
</commit_message>
<xml_diff>
--- a/videoslides/cleverbox-access-einstieg-slides.pptx
+++ b/videoslides/cleverbox-access-einstieg-slides.pptx
@@ -16,9 +16,10 @@
     <p:sldId id="264" r:id="rId10"/>
     <p:sldId id="265" r:id="rId11"/>
     <p:sldId id="266" r:id="rId12"/>
+    <p:sldId id="267" r:id="rId13"/>
   </p:sldIdLst>
   <p:notesMasterIdLst>
-    <p:notesMasterId r:id="rId13"/>
+    <p:notesMasterId r:id="rId14"/>
   </p:notesMasterIdLst>
   <p:sldSz cx="12192000" cy="6858000"/>
   <p:notesSz cx="6858000" cy="12192000"/>
@@ -730,6 +731,94 @@
 </p:notes>
 </file>
 
+<file path=ppt/notesSlides/notesSlide12.xml><?xml version="1.0" encoding="utf-8"?>
+<p:notes xmlns:a="http://schemas.openxmlformats.org/drawingml/2006/main" xmlns:r="http://schemas.openxmlformats.org/officeDocument/2006/relationships" xmlns:p="http://schemas.openxmlformats.org/presentationml/2006/main">
+  <p:cSld>
+    <p:spTree>
+      <p:nvGrpSpPr>
+        <p:cNvPr id="1" name=""/>
+        <p:cNvGrpSpPr/>
+        <p:nvPr/>
+      </p:nvGrpSpPr>
+      <p:grpSpPr>
+        <a:xfrm>
+          <a:off x="0" y="0"/>
+          <a:ext cx="0" cy="0"/>
+          <a:chOff x="0" y="0"/>
+          <a:chExt cx="0" cy="0"/>
+        </a:xfrm>
+      </p:grpSpPr>
+      <p:sp>
+        <p:nvSpPr>
+          <p:cNvPr id="2" name="Slide Image Placeholder 1"/>
+          <p:cNvSpPr>
+            <a:spLocks noGrp="1" noRot="1" noChangeAspect="1"/>
+          </p:cNvSpPr>
+          <p:nvPr>
+            <p:ph type="sldImg"/>
+          </p:nvPr>
+        </p:nvSpPr>
+        <p:spPr/>
+      </p:sp>
+      <p:sp>
+        <p:nvSpPr>
+          <p:cNvPr id="3" name="Notes Placeholder 2"/>
+          <p:cNvSpPr>
+            <a:spLocks noGrp="1"/>
+          </p:cNvSpPr>
+          <p:nvPr>
+            <p:ph type="body" idx="1"/>
+          </p:nvPr>
+        </p:nvSpPr>
+        <p:spPr/>
+        <p:txBody>
+          <a:bodyPr/>
+          <a:lstStyle/>
+          <a:p>
+            <a:r>
+              <a:rPr lang="en-US" dirty="0"/>
+              <a:t>Folie 12 – Überleitung (nicht im Skript): Hier zur Bildschirmaufnahme von Access wechseln.</a:t>
+            </a:r>
+            <a:endParaRPr lang="en-US" dirty="0"/>
+          </a:p>
+        </p:txBody>
+      </p:sp>
+      <p:sp>
+        <p:nvSpPr>
+          <p:cNvPr id="4" name="Slide Number Placeholder 3"/>
+          <p:cNvSpPr>
+            <a:spLocks noGrp="1"/>
+          </p:cNvSpPr>
+          <p:nvPr>
+            <p:ph type="sldNum" sz="quarter" idx="10"/>
+          </p:nvPr>
+        </p:nvSpPr>
+        <p:spPr/>
+        <p:txBody>
+          <a:bodyPr/>
+          <a:lstStyle/>
+          <a:p>
+            <a:fld id="{F7021451-1387-4CA6-816F-3879F97B5CBC}" type="slidenum">
+              <a:rPr lang="en-US"/>
+              <a:t>12</a:t>
+            </a:fld>
+            <a:endParaRPr lang="en-US"/>
+          </a:p>
+        </p:txBody>
+      </p:sp>
+    </p:spTree>
+    <p:extLst>
+      <p:ext uri="{BB962C8B-B14F-4D97-AF65-F5344CB8AC3E}">
+        <p14:creationId xmlns:p14="http://schemas.microsoft.com/office/powerpoint/2010/main" val="1024086991"/>
+      </p:ext>
+    </p:extLst>
+  </p:cSld>
+  <p:clrMapOvr>
+    <a:masterClrMapping/>
+  </p:clrMapOvr>
+</p:notes>
+</file>
+
 <file path=ppt/notesSlides/notesSlide2.xml><?xml version="1.0" encoding="utf-8"?>
 <p:notes xmlns:a="http://schemas.openxmlformats.org/drawingml/2006/main" xmlns:r="http://schemas.openxmlformats.org/officeDocument/2006/relationships" xmlns:p="http://schemas.openxmlformats.org/presentationml/2006/main">
   <p:cSld>
@@ -3680,6 +3769,1272 @@
               <a:t>Rückgabedatum – Datum/Uhrzeit</a:t>
             </a:r>
             <a:endParaRPr lang="en-US" sz="1700" dirty="0"/>
+          </a:p>
+        </p:txBody>
+      </p:sp>
+    </p:spTree>
+  </p:cSld>
+  <p:clrMapOvr>
+    <a:masterClrMapping/>
+  </p:clrMapOvr>
+</p:sld>
+</file>
+
+<file path=ppt/slides/slide12.xml><?xml version="1.0" encoding="utf-8"?>
+<p:sld xmlns:a="http://schemas.openxmlformats.org/drawingml/2006/main" xmlns:r="http://schemas.openxmlformats.org/officeDocument/2006/relationships" xmlns:p="http://schemas.openxmlformats.org/presentationml/2006/main">
+  <p:cSld name="Slide 12">
+    <p:spTree>
+      <p:nvGrpSpPr>
+        <p:cNvPr id="1" name=""/>
+        <p:cNvGrpSpPr/>
+        <p:nvPr/>
+      </p:nvGrpSpPr>
+      <p:grpSpPr>
+        <a:xfrm>
+          <a:off x="0" y="0"/>
+          <a:ext cx="0" cy="0"/>
+          <a:chOff x="0" y="0"/>
+          <a:chExt cx="0" cy="0"/>
+        </a:xfrm>
+      </p:grpSpPr>
+      <p:sp>
+        <p:nvSpPr>
+          <p:cNvPr id="3" name="Text 0"/>
+          <p:cNvSpPr txBox="1"/>
+          <p:nvPr/>
+        </p:nvSpPr>
+        <p:spPr>
+          <a:xfrm>
+            <a:off x="640080" y="1097280"/>
+            <a:ext cx="7315200" cy="365760"/>
+          </a:xfrm>
+          <a:prstGeom prst="rect">
+            <a:avLst/>
+          </a:prstGeom>
+          <a:noFill/>
+          <a:ln/>
+        </p:spPr>
+        <p:txBody>
+          <a:bodyPr wrap="square" lIns="0" tIns="0" rIns="0" bIns="0" rtlCol="0" anchor="t"/>
+          <a:lstStyle/>
+          <a:p>
+            <a:pPr indent="0" marL="0">
+              <a:buNone/>
+            </a:pPr>
+            <a:r>
+              <a:rPr lang="en-US" sz="1800" b="1" dirty="0">
+                <a:solidFill>
+                  <a:srgbClr val="26720A"/>
+                </a:solidFill>
+                <a:latin typeface="Poppins" pitchFamily="34" charset="0"/>
+                <a:ea typeface="Poppins" pitchFamily="34" charset="-122"/>
+                <a:cs typeface="Poppins" pitchFamily="34" charset="-120"/>
+              </a:rPr>
+              <a:t>Jetzt geht es los</a:t>
+            </a:r>
+            <a:endParaRPr lang="en-US" sz="1800" dirty="0"/>
+          </a:p>
+        </p:txBody>
+      </p:sp>
+      <p:sp>
+        <p:nvSpPr>
+          <p:cNvPr id="4" name="Text 1"/>
+          <p:cNvSpPr txBox="1"/>
+          <p:nvPr/>
+        </p:nvSpPr>
+        <p:spPr>
+          <a:xfrm>
+            <a:off x="640080" y="1600200"/>
+            <a:ext cx="5669280" cy="2743200"/>
+          </a:xfrm>
+          <a:prstGeom prst="rect">
+            <a:avLst/>
+          </a:prstGeom>
+          <a:noFill/>
+          <a:ln/>
+        </p:spPr>
+        <p:txBody>
+          <a:bodyPr wrap="square" lIns="0" tIns="0" rIns="0" bIns="0" rtlCol="0" anchor="t"/>
+          <a:lstStyle/>
+          <a:p>
+            <a:pPr indent="0" marL="0">
+              <a:lnSpc>
+                <a:spcPct val="105000"/>
+              </a:lnSpc>
+              <a:buNone/>
+            </a:pPr>
+            <a:r>
+              <a:rPr lang="en-US" sz="4400" dirty="0">
+                <a:solidFill>
+                  <a:srgbClr val="0E1F0C"/>
+                </a:solidFill>
+                <a:latin typeface="Poppins" pitchFamily="34" charset="0"/>
+                <a:ea typeface="Poppins" pitchFamily="34" charset="-122"/>
+                <a:cs typeface="Poppins" pitchFamily="34" charset="-120"/>
+              </a:rPr>
+              <a:t>Jetzt öffnen wir </a:t>
+            </a:r>
+            <a:pPr indent="0" marL="0">
+              <a:lnSpc>
+                <a:spcPct val="105000"/>
+              </a:lnSpc>
+              <a:buNone/>
+            </a:pPr>
+            <a:r>
+              <a:rPr lang="en-US" sz="4400" dirty="0">
+                <a:solidFill>
+                  <a:srgbClr val="26720A"/>
+                </a:solidFill>
+                <a:highlight>
+                  <a:srgbClr val="B1FF37"/>
+                </a:highlight>
+                <a:latin typeface="Poppins" pitchFamily="34" charset="0"/>
+                <a:ea typeface="Poppins" pitchFamily="34" charset="-122"/>
+                <a:cs typeface="Poppins" pitchFamily="34" charset="-120"/>
+              </a:rPr>
+              <a:t>Access.</a:t>
+            </a:r>
+            <a:endParaRPr lang="en-US" sz="4400" dirty="0"/>
+          </a:p>
+        </p:txBody>
+      </p:sp>
+      <p:sp>
+        <p:nvSpPr>
+          <p:cNvPr id="5" name="Text 2"/>
+          <p:cNvSpPr txBox="1"/>
+          <p:nvPr/>
+        </p:nvSpPr>
+        <p:spPr>
+          <a:xfrm>
+            <a:off x="640080" y="4206240"/>
+            <a:ext cx="5486400" cy="1645920"/>
+          </a:xfrm>
+          <a:prstGeom prst="rect">
+            <a:avLst/>
+          </a:prstGeom>
+          <a:noFill/>
+          <a:ln/>
+        </p:spPr>
+        <p:txBody>
+          <a:bodyPr wrap="square" lIns="0" tIns="0" rIns="0" bIns="0" rtlCol="0" anchor="t"/>
+          <a:lstStyle/>
+          <a:p>
+            <a:pPr indent="0" marL="0">
+              <a:lnSpc>
+                <a:spcPct val="120000"/>
+              </a:lnSpc>
+              <a:buNone/>
+            </a:pPr>
+            <a:r>
+              <a:rPr lang="en-US" sz="1800" dirty="0">
+                <a:solidFill>
+                  <a:srgbClr val="5B6B50"/>
+                </a:solidFill>
+                <a:latin typeface="Poppins" pitchFamily="34" charset="0"/>
+                <a:ea typeface="Poppins" pitchFamily="34" charset="-122"/>
+                <a:cs typeface="Poppins" pitchFamily="34" charset="-120"/>
+              </a:rPr>
+              <a:t>Leg deinen Zettel bereit – wir bauen die Tabelle nach deinem Plan.</a:t>
+            </a:r>
+            <a:endParaRPr lang="en-US" sz="1800" dirty="0"/>
+          </a:p>
+        </p:txBody>
+      </p:sp>
+      <p:sp>
+        <p:nvSpPr>
+          <p:cNvPr id="6" name="Shape 3"/>
+          <p:cNvSpPr/>
+          <p:nvPr/>
+        </p:nvSpPr>
+        <p:spPr>
+          <a:xfrm>
+            <a:off x="6720840" y="1234440"/>
+            <a:ext cx="2103120" cy="2651760"/>
+          </a:xfrm>
+          <a:prstGeom prst="rect">
+            <a:avLst/>
+          </a:prstGeom>
+          <a:solidFill>
+            <a:srgbClr val="B8D98A"/>
+          </a:solidFill>
+          <a:ln w="12700">
+            <a:solidFill>
+              <a:srgbClr val="B8D98A"/>
+            </a:solidFill>
+            <a:prstDash val="solid"/>
+          </a:ln>
+        </p:spPr>
+      </p:sp>
+      <p:sp>
+        <p:nvSpPr>
+          <p:cNvPr id="7" name="Shape 4"/>
+          <p:cNvSpPr/>
+          <p:nvPr/>
+        </p:nvSpPr>
+        <p:spPr>
+          <a:xfrm>
+            <a:off x="6629400" y="1143000"/>
+            <a:ext cx="2103120" cy="2651760"/>
+          </a:xfrm>
+          <a:prstGeom prst="rect">
+            <a:avLst/>
+          </a:prstGeom>
+          <a:solidFill>
+            <a:srgbClr val="B1FF37"/>
+          </a:solidFill>
+          <a:ln w="25400">
+            <a:solidFill>
+              <a:srgbClr val="12301A"/>
+            </a:solidFill>
+            <a:prstDash val="solid"/>
+          </a:ln>
+        </p:spPr>
+      </p:sp>
+      <p:sp>
+        <p:nvSpPr>
+          <p:cNvPr id="8" name="Shape 5"/>
+          <p:cNvSpPr/>
+          <p:nvPr/>
+        </p:nvSpPr>
+        <p:spPr>
+          <a:xfrm>
+            <a:off x="7543800" y="1005840"/>
+            <a:ext cx="274320" cy="274320"/>
+          </a:xfrm>
+          <a:prstGeom prst="ellipse">
+            <a:avLst/>
+          </a:prstGeom>
+          <a:solidFill>
+            <a:srgbClr val="FF7A45"/>
+          </a:solidFill>
+          <a:ln w="25400">
+            <a:solidFill>
+              <a:srgbClr val="12301A"/>
+            </a:solidFill>
+            <a:prstDash val="solid"/>
+          </a:ln>
+        </p:spPr>
+      </p:sp>
+      <p:sp>
+        <p:nvSpPr>
+          <p:cNvPr id="9" name="Text 6"/>
+          <p:cNvSpPr txBox="1"/>
+          <p:nvPr/>
+        </p:nvSpPr>
+        <p:spPr>
+          <a:xfrm>
+            <a:off x="6766560" y="1417320"/>
+            <a:ext cx="1828800" cy="365760"/>
+          </a:xfrm>
+          <a:prstGeom prst="rect">
+            <a:avLst/>
+          </a:prstGeom>
+          <a:noFill/>
+          <a:ln/>
+        </p:spPr>
+        <p:txBody>
+          <a:bodyPr wrap="square" lIns="0" tIns="0" rIns="0" bIns="0" rtlCol="0" anchor="t"/>
+          <a:lstStyle/>
+          <a:p>
+            <a:pPr algn="ctr" indent="0" marL="0">
+              <a:buNone/>
+            </a:pPr>
+            <a:r>
+              <a:rPr lang="en-US" sz="1500" b="1" dirty="0">
+                <a:solidFill>
+                  <a:srgbClr val="0E1F0C"/>
+                </a:solidFill>
+                <a:latin typeface="Poppins" pitchFamily="34" charset="0"/>
+                <a:ea typeface="Poppins" pitchFamily="34" charset="-122"/>
+                <a:cs typeface="Poppins" pitchFamily="34" charset="-120"/>
+              </a:rPr>
+              <a:t>Mein Plan</a:t>
+            </a:r>
+            <a:endParaRPr lang="en-US" sz="1500" dirty="0"/>
+          </a:p>
+        </p:txBody>
+      </p:sp>
+      <p:sp>
+        <p:nvSpPr>
+          <p:cNvPr id="10" name="Shape 7"/>
+          <p:cNvSpPr/>
+          <p:nvPr/>
+        </p:nvSpPr>
+        <p:spPr>
+          <a:xfrm>
+            <a:off x="6858000" y="1965960"/>
+            <a:ext cx="1645920" cy="0"/>
+          </a:xfrm>
+          <a:prstGeom prst="line">
+            <a:avLst/>
+          </a:prstGeom>
+          <a:noFill/>
+          <a:ln w="25400">
+            <a:solidFill>
+              <a:srgbClr val="12301A"/>
+            </a:solidFill>
+            <a:prstDash val="solid"/>
+          </a:ln>
+        </p:spPr>
+      </p:sp>
+      <p:sp>
+        <p:nvSpPr>
+          <p:cNvPr id="11" name="Shape 8"/>
+          <p:cNvSpPr/>
+          <p:nvPr/>
+        </p:nvSpPr>
+        <p:spPr>
+          <a:xfrm>
+            <a:off x="6858000" y="2377440"/>
+            <a:ext cx="1645920" cy="0"/>
+          </a:xfrm>
+          <a:prstGeom prst="line">
+            <a:avLst/>
+          </a:prstGeom>
+          <a:noFill/>
+          <a:ln w="25400">
+            <a:solidFill>
+              <a:srgbClr val="12301A"/>
+            </a:solidFill>
+            <a:prstDash val="solid"/>
+          </a:ln>
+        </p:spPr>
+      </p:sp>
+      <p:sp>
+        <p:nvSpPr>
+          <p:cNvPr id="12" name="Shape 9"/>
+          <p:cNvSpPr/>
+          <p:nvPr/>
+        </p:nvSpPr>
+        <p:spPr>
+          <a:xfrm>
+            <a:off x="6858000" y="2788920"/>
+            <a:ext cx="1645920" cy="0"/>
+          </a:xfrm>
+          <a:prstGeom prst="line">
+            <a:avLst/>
+          </a:prstGeom>
+          <a:noFill/>
+          <a:ln w="25400">
+            <a:solidFill>
+              <a:srgbClr val="12301A"/>
+            </a:solidFill>
+            <a:prstDash val="solid"/>
+          </a:ln>
+        </p:spPr>
+      </p:sp>
+      <p:sp>
+        <p:nvSpPr>
+          <p:cNvPr id="13" name="Shape 10"/>
+          <p:cNvSpPr/>
+          <p:nvPr/>
+        </p:nvSpPr>
+        <p:spPr>
+          <a:xfrm>
+            <a:off x="6858000" y="3200400"/>
+            <a:ext cx="1645920" cy="0"/>
+          </a:xfrm>
+          <a:prstGeom prst="line">
+            <a:avLst/>
+          </a:prstGeom>
+          <a:noFill/>
+          <a:ln w="25400">
+            <a:solidFill>
+              <a:srgbClr val="12301A"/>
+            </a:solidFill>
+            <a:prstDash val="solid"/>
+          </a:ln>
+        </p:spPr>
+      </p:sp>
+      <p:sp>
+        <p:nvSpPr>
+          <p:cNvPr id="14" name="Shape 11"/>
+          <p:cNvSpPr/>
+          <p:nvPr/>
+        </p:nvSpPr>
+        <p:spPr>
+          <a:xfrm>
+            <a:off x="9006840" y="2240280"/>
+            <a:ext cx="640080" cy="457200"/>
+          </a:xfrm>
+          <a:prstGeom prst="rightArrow">
+            <a:avLst/>
+          </a:prstGeom>
+          <a:solidFill>
+            <a:srgbClr val="26720A"/>
+          </a:solidFill>
+          <a:ln w="12700">
+            <a:solidFill>
+              <a:srgbClr val="26720A"/>
+            </a:solidFill>
+            <a:prstDash val="solid"/>
+          </a:ln>
+        </p:spPr>
+      </p:sp>
+      <p:sp>
+        <p:nvSpPr>
+          <p:cNvPr id="15" name="Shape 12"/>
+          <p:cNvSpPr/>
+          <p:nvPr/>
+        </p:nvSpPr>
+        <p:spPr>
+          <a:xfrm>
+            <a:off x="9784080" y="1828800"/>
+            <a:ext cx="1737360" cy="502920"/>
+          </a:xfrm>
+          <a:prstGeom prst="ellipse">
+            <a:avLst/>
+          </a:prstGeom>
+          <a:solidFill>
+            <a:srgbClr val="12301A"/>
+          </a:solidFill>
+          <a:ln w="12700">
+            <a:solidFill>
+              <a:srgbClr val="12301A"/>
+            </a:solidFill>
+            <a:prstDash val="solid"/>
+          </a:ln>
+        </p:spPr>
+      </p:sp>
+      <p:sp>
+        <p:nvSpPr>
+          <p:cNvPr id="16" name="Shape 13"/>
+          <p:cNvSpPr/>
+          <p:nvPr/>
+        </p:nvSpPr>
+        <p:spPr>
+          <a:xfrm>
+            <a:off x="9784080" y="1627632"/>
+            <a:ext cx="1737360" cy="457200"/>
+          </a:xfrm>
+          <a:prstGeom prst="rect">
+            <a:avLst/>
+          </a:prstGeom>
+          <a:solidFill>
+            <a:srgbClr val="12301A"/>
+          </a:solidFill>
+          <a:ln w="12700">
+            <a:solidFill>
+              <a:srgbClr val="12301A"/>
+            </a:solidFill>
+            <a:prstDash val="solid"/>
+          </a:ln>
+        </p:spPr>
+      </p:sp>
+      <p:sp>
+        <p:nvSpPr>
+          <p:cNvPr id="17" name="Shape 14"/>
+          <p:cNvSpPr/>
+          <p:nvPr/>
+        </p:nvSpPr>
+        <p:spPr>
+          <a:xfrm>
+            <a:off x="9784080" y="1371600"/>
+            <a:ext cx="1737360" cy="502920"/>
+          </a:xfrm>
+          <a:prstGeom prst="ellipse">
+            <a:avLst/>
+          </a:prstGeom>
+          <a:solidFill>
+            <a:srgbClr val="B1FF37"/>
+          </a:solidFill>
+          <a:ln w="31750">
+            <a:solidFill>
+              <a:srgbClr val="12301A"/>
+            </a:solidFill>
+            <a:prstDash val="solid"/>
+          </a:ln>
+        </p:spPr>
+      </p:sp>
+      <p:sp>
+        <p:nvSpPr>
+          <p:cNvPr id="18" name="Shape 15"/>
+          <p:cNvSpPr/>
+          <p:nvPr/>
+        </p:nvSpPr>
+        <p:spPr>
+          <a:xfrm>
+            <a:off x="9784080" y="2606040"/>
+            <a:ext cx="1737360" cy="502920"/>
+          </a:xfrm>
+          <a:prstGeom prst="ellipse">
+            <a:avLst/>
+          </a:prstGeom>
+          <a:solidFill>
+            <a:srgbClr val="12301A"/>
+          </a:solidFill>
+          <a:ln w="12700">
+            <a:solidFill>
+              <a:srgbClr val="12301A"/>
+            </a:solidFill>
+            <a:prstDash val="solid"/>
+          </a:ln>
+        </p:spPr>
+      </p:sp>
+      <p:sp>
+        <p:nvSpPr>
+          <p:cNvPr id="19" name="Shape 16"/>
+          <p:cNvSpPr/>
+          <p:nvPr/>
+        </p:nvSpPr>
+        <p:spPr>
+          <a:xfrm>
+            <a:off x="9784080" y="2404872"/>
+            <a:ext cx="1737360" cy="457200"/>
+          </a:xfrm>
+          <a:prstGeom prst="rect">
+            <a:avLst/>
+          </a:prstGeom>
+          <a:solidFill>
+            <a:srgbClr val="12301A"/>
+          </a:solidFill>
+          <a:ln w="12700">
+            <a:solidFill>
+              <a:srgbClr val="12301A"/>
+            </a:solidFill>
+            <a:prstDash val="solid"/>
+          </a:ln>
+        </p:spPr>
+      </p:sp>
+      <p:sp>
+        <p:nvSpPr>
+          <p:cNvPr id="20" name="Shape 17"/>
+          <p:cNvSpPr/>
+          <p:nvPr/>
+        </p:nvSpPr>
+        <p:spPr>
+          <a:xfrm>
+            <a:off x="9784080" y="2148840"/>
+            <a:ext cx="1737360" cy="502920"/>
+          </a:xfrm>
+          <a:prstGeom prst="ellipse">
+            <a:avLst/>
+          </a:prstGeom>
+          <a:solidFill>
+            <a:srgbClr val="C9EF8F"/>
+          </a:solidFill>
+          <a:ln w="31750">
+            <a:solidFill>
+              <a:srgbClr val="12301A"/>
+            </a:solidFill>
+            <a:prstDash val="solid"/>
+          </a:ln>
+        </p:spPr>
+      </p:sp>
+      <p:sp>
+        <p:nvSpPr>
+          <p:cNvPr id="21" name="Shape 18"/>
+          <p:cNvSpPr/>
+          <p:nvPr/>
+        </p:nvSpPr>
+        <p:spPr>
+          <a:xfrm>
+            <a:off x="9784080" y="3383280"/>
+            <a:ext cx="1737360" cy="502920"/>
+          </a:xfrm>
+          <a:prstGeom prst="ellipse">
+            <a:avLst/>
+          </a:prstGeom>
+          <a:solidFill>
+            <a:srgbClr val="12301A"/>
+          </a:solidFill>
+          <a:ln w="12700">
+            <a:solidFill>
+              <a:srgbClr val="12301A"/>
+            </a:solidFill>
+            <a:prstDash val="solid"/>
+          </a:ln>
+        </p:spPr>
+      </p:sp>
+      <p:sp>
+        <p:nvSpPr>
+          <p:cNvPr id="22" name="Shape 19"/>
+          <p:cNvSpPr/>
+          <p:nvPr/>
+        </p:nvSpPr>
+        <p:spPr>
+          <a:xfrm>
+            <a:off x="9784080" y="3182112"/>
+            <a:ext cx="1737360" cy="457200"/>
+          </a:xfrm>
+          <a:prstGeom prst="rect">
+            <a:avLst/>
+          </a:prstGeom>
+          <a:solidFill>
+            <a:srgbClr val="12301A"/>
+          </a:solidFill>
+          <a:ln w="12700">
+            <a:solidFill>
+              <a:srgbClr val="12301A"/>
+            </a:solidFill>
+            <a:prstDash val="solid"/>
+          </a:ln>
+        </p:spPr>
+      </p:sp>
+      <p:sp>
+        <p:nvSpPr>
+          <p:cNvPr id="23" name="Shape 20"/>
+          <p:cNvSpPr/>
+          <p:nvPr/>
+        </p:nvSpPr>
+        <p:spPr>
+          <a:xfrm>
+            <a:off x="9784080" y="2926080"/>
+            <a:ext cx="1737360" cy="502920"/>
+          </a:xfrm>
+          <a:prstGeom prst="ellipse">
+            <a:avLst/>
+          </a:prstGeom>
+          <a:solidFill>
+            <a:srgbClr val="C9EF8F"/>
+          </a:solidFill>
+          <a:ln w="31750">
+            <a:solidFill>
+              <a:srgbClr val="12301A"/>
+            </a:solidFill>
+            <a:prstDash val="solid"/>
+          </a:ln>
+        </p:spPr>
+      </p:sp>
+      <p:sp>
+        <p:nvSpPr>
+          <p:cNvPr id="24" name="Shape 21"/>
+          <p:cNvSpPr/>
+          <p:nvPr/>
+        </p:nvSpPr>
+        <p:spPr>
+          <a:xfrm>
+            <a:off x="6629400" y="4480560"/>
+            <a:ext cx="1737360" cy="502920"/>
+          </a:xfrm>
+          <a:prstGeom prst="rect">
+            <a:avLst/>
+          </a:prstGeom>
+          <a:solidFill>
+            <a:srgbClr val="12301A"/>
+          </a:solidFill>
+          <a:ln w="12700">
+            <a:solidFill>
+              <a:srgbClr val="B8D98A"/>
+            </a:solidFill>
+            <a:prstDash val="solid"/>
+          </a:ln>
+        </p:spPr>
+      </p:sp>
+      <p:sp>
+        <p:nvSpPr>
+          <p:cNvPr id="25" name="Text 22"/>
+          <p:cNvSpPr txBox="1"/>
+          <p:nvPr/>
+        </p:nvSpPr>
+        <p:spPr>
+          <a:xfrm>
+            <a:off x="6720840" y="4480560"/>
+            <a:ext cx="1554480" cy="502920"/>
+          </a:xfrm>
+          <a:prstGeom prst="rect">
+            <a:avLst/>
+          </a:prstGeom>
+          <a:noFill/>
+          <a:ln/>
+        </p:spPr>
+        <p:txBody>
+          <a:bodyPr wrap="square" lIns="0" tIns="0" rIns="0" bIns="0" rtlCol="0" anchor="ctr"/>
+          <a:lstStyle/>
+          <a:p>
+            <a:pPr algn="l" indent="0" marL="0">
+              <a:buNone/>
+            </a:pPr>
+            <a:r>
+              <a:rPr lang="en-US" sz="1400" b="1" dirty="0">
+                <a:solidFill>
+                  <a:srgbClr val="FBFFF4"/>
+                </a:solidFill>
+                <a:latin typeface="Poppins" pitchFamily="34" charset="0"/>
+                <a:ea typeface="Poppins" pitchFamily="34" charset="-122"/>
+                <a:cs typeface="Poppins" pitchFamily="34" charset="-120"/>
+              </a:rPr>
+              <a:t>Buchnummer</a:t>
+            </a:r>
+            <a:endParaRPr lang="en-US" sz="1400" dirty="0"/>
+          </a:p>
+        </p:txBody>
+      </p:sp>
+      <p:sp>
+        <p:nvSpPr>
+          <p:cNvPr id="26" name="Shape 23"/>
+          <p:cNvSpPr/>
+          <p:nvPr/>
+        </p:nvSpPr>
+        <p:spPr>
+          <a:xfrm>
+            <a:off x="8366760" y="4480560"/>
+            <a:ext cx="1554480" cy="502920"/>
+          </a:xfrm>
+          <a:prstGeom prst="rect">
+            <a:avLst/>
+          </a:prstGeom>
+          <a:solidFill>
+            <a:srgbClr val="12301A"/>
+          </a:solidFill>
+          <a:ln w="12700">
+            <a:solidFill>
+              <a:srgbClr val="B8D98A"/>
+            </a:solidFill>
+            <a:prstDash val="solid"/>
+          </a:ln>
+        </p:spPr>
+      </p:sp>
+      <p:sp>
+        <p:nvSpPr>
+          <p:cNvPr id="27" name="Text 24"/>
+          <p:cNvSpPr txBox="1"/>
+          <p:nvPr/>
+        </p:nvSpPr>
+        <p:spPr>
+          <a:xfrm>
+            <a:off x="8458200" y="4480560"/>
+            <a:ext cx="1371600" cy="502920"/>
+          </a:xfrm>
+          <a:prstGeom prst="rect">
+            <a:avLst/>
+          </a:prstGeom>
+          <a:noFill/>
+          <a:ln/>
+        </p:spPr>
+        <p:txBody>
+          <a:bodyPr wrap="square" lIns="0" tIns="0" rIns="0" bIns="0" rtlCol="0" anchor="ctr"/>
+          <a:lstStyle/>
+          <a:p>
+            <a:pPr algn="l" indent="0" marL="0">
+              <a:buNone/>
+            </a:pPr>
+            <a:r>
+              <a:rPr lang="en-US" sz="1400" b="1" dirty="0">
+                <a:solidFill>
+                  <a:srgbClr val="FBFFF4"/>
+                </a:solidFill>
+                <a:latin typeface="Poppins" pitchFamily="34" charset="0"/>
+                <a:ea typeface="Poppins" pitchFamily="34" charset="-122"/>
+                <a:cs typeface="Poppins" pitchFamily="34" charset="-120"/>
+              </a:rPr>
+              <a:t>Titel</a:t>
+            </a:r>
+            <a:endParaRPr lang="en-US" sz="1400" dirty="0"/>
+          </a:p>
+        </p:txBody>
+      </p:sp>
+      <p:sp>
+        <p:nvSpPr>
+          <p:cNvPr id="28" name="Shape 25"/>
+          <p:cNvSpPr/>
+          <p:nvPr/>
+        </p:nvSpPr>
+        <p:spPr>
+          <a:xfrm>
+            <a:off x="9921240" y="4480560"/>
+            <a:ext cx="1554480" cy="502920"/>
+          </a:xfrm>
+          <a:prstGeom prst="rect">
+            <a:avLst/>
+          </a:prstGeom>
+          <a:solidFill>
+            <a:srgbClr val="12301A"/>
+          </a:solidFill>
+          <a:ln w="12700">
+            <a:solidFill>
+              <a:srgbClr val="B8D98A"/>
+            </a:solidFill>
+            <a:prstDash val="solid"/>
+          </a:ln>
+        </p:spPr>
+      </p:sp>
+      <p:sp>
+        <p:nvSpPr>
+          <p:cNvPr id="29" name="Text 26"/>
+          <p:cNvSpPr txBox="1"/>
+          <p:nvPr/>
+        </p:nvSpPr>
+        <p:spPr>
+          <a:xfrm>
+            <a:off x="10012680" y="4480560"/>
+            <a:ext cx="1371600" cy="502920"/>
+          </a:xfrm>
+          <a:prstGeom prst="rect">
+            <a:avLst/>
+          </a:prstGeom>
+          <a:noFill/>
+          <a:ln/>
+        </p:spPr>
+        <p:txBody>
+          <a:bodyPr wrap="square" lIns="0" tIns="0" rIns="0" bIns="0" rtlCol="0" anchor="ctr"/>
+          <a:lstStyle/>
+          <a:p>
+            <a:pPr algn="l" indent="0" marL="0">
+              <a:buNone/>
+            </a:pPr>
+            <a:r>
+              <a:rPr lang="en-US" sz="1400" b="1" dirty="0">
+                <a:solidFill>
+                  <a:srgbClr val="FBFFF4"/>
+                </a:solidFill>
+                <a:latin typeface="Poppins" pitchFamily="34" charset="0"/>
+                <a:ea typeface="Poppins" pitchFamily="34" charset="-122"/>
+                <a:cs typeface="Poppins" pitchFamily="34" charset="-120"/>
+              </a:rPr>
+              <a:t>Autor</a:t>
+            </a:r>
+            <a:endParaRPr lang="en-US" sz="1400" dirty="0"/>
+          </a:p>
+        </p:txBody>
+      </p:sp>
+      <p:sp>
+        <p:nvSpPr>
+          <p:cNvPr id="30" name="Shape 27"/>
+          <p:cNvSpPr/>
+          <p:nvPr/>
+        </p:nvSpPr>
+        <p:spPr>
+          <a:xfrm>
+            <a:off x="6629400" y="4983480"/>
+            <a:ext cx="1737360" cy="502920"/>
+          </a:xfrm>
+          <a:prstGeom prst="rect">
+            <a:avLst/>
+          </a:prstGeom>
+          <a:solidFill>
+            <a:srgbClr val="FBFFF4"/>
+          </a:solidFill>
+          <a:ln w="12700">
+            <a:solidFill>
+              <a:srgbClr val="B8D98A"/>
+            </a:solidFill>
+            <a:prstDash val="solid"/>
+          </a:ln>
+        </p:spPr>
+      </p:sp>
+      <p:sp>
+        <p:nvSpPr>
+          <p:cNvPr id="31" name="Text 28"/>
+          <p:cNvSpPr txBox="1"/>
+          <p:nvPr/>
+        </p:nvSpPr>
+        <p:spPr>
+          <a:xfrm>
+            <a:off x="6720840" y="4983480"/>
+            <a:ext cx="1554480" cy="502920"/>
+          </a:xfrm>
+          <a:prstGeom prst="rect">
+            <a:avLst/>
+          </a:prstGeom>
+          <a:noFill/>
+          <a:ln/>
+        </p:spPr>
+        <p:txBody>
+          <a:bodyPr wrap="square" lIns="0" tIns="0" rIns="0" bIns="0" rtlCol="0" anchor="ctr"/>
+          <a:lstStyle/>
+          <a:p>
+            <a:pPr algn="l" indent="0" marL="0">
+              <a:buNone/>
+            </a:pPr>
+            <a:r>
+              <a:rPr lang="en-US" sz="1400" dirty="0">
+                <a:solidFill>
+                  <a:srgbClr val="0E1F0C"/>
+                </a:solidFill>
+                <a:latin typeface="Poppins" pitchFamily="34" charset="0"/>
+                <a:ea typeface="Poppins" pitchFamily="34" charset="-122"/>
+                <a:cs typeface="Poppins" pitchFamily="34" charset="-120"/>
+              </a:rPr>
+              <a:t>1</a:t>
+            </a:r>
+            <a:endParaRPr lang="en-US" sz="1400" dirty="0"/>
+          </a:p>
+        </p:txBody>
+      </p:sp>
+      <p:sp>
+        <p:nvSpPr>
+          <p:cNvPr id="32" name="Shape 29"/>
+          <p:cNvSpPr/>
+          <p:nvPr/>
+        </p:nvSpPr>
+        <p:spPr>
+          <a:xfrm>
+            <a:off x="8366760" y="4983480"/>
+            <a:ext cx="1554480" cy="502920"/>
+          </a:xfrm>
+          <a:prstGeom prst="rect">
+            <a:avLst/>
+          </a:prstGeom>
+          <a:solidFill>
+            <a:srgbClr val="FBFFF4"/>
+          </a:solidFill>
+          <a:ln w="12700">
+            <a:solidFill>
+              <a:srgbClr val="B8D98A"/>
+            </a:solidFill>
+            <a:prstDash val="solid"/>
+          </a:ln>
+        </p:spPr>
+      </p:sp>
+      <p:sp>
+        <p:nvSpPr>
+          <p:cNvPr id="33" name="Text 30"/>
+          <p:cNvSpPr txBox="1"/>
+          <p:nvPr/>
+        </p:nvSpPr>
+        <p:spPr>
+          <a:xfrm>
+            <a:off x="8458200" y="4983480"/>
+            <a:ext cx="1371600" cy="502920"/>
+          </a:xfrm>
+          <a:prstGeom prst="rect">
+            <a:avLst/>
+          </a:prstGeom>
+          <a:noFill/>
+          <a:ln/>
+        </p:spPr>
+        <p:txBody>
+          <a:bodyPr wrap="square" lIns="0" tIns="0" rIns="0" bIns="0" rtlCol="0" anchor="ctr"/>
+          <a:lstStyle/>
+          <a:p>
+            <a:pPr algn="l" indent="0" marL="0">
+              <a:buNone/>
+            </a:pPr>
+            <a:r>
+              <a:rPr lang="en-US" sz="1400" dirty="0">
+                <a:solidFill>
+                  <a:srgbClr val="0E1F0C"/>
+                </a:solidFill>
+                <a:latin typeface="Poppins" pitchFamily="34" charset="0"/>
+                <a:ea typeface="Poppins" pitchFamily="34" charset="-122"/>
+                <a:cs typeface="Poppins" pitchFamily="34" charset="-120"/>
+              </a:rPr>
+              <a:t>…</a:t>
+            </a:r>
+            <a:endParaRPr lang="en-US" sz="1400" dirty="0"/>
+          </a:p>
+        </p:txBody>
+      </p:sp>
+      <p:sp>
+        <p:nvSpPr>
+          <p:cNvPr id="34" name="Shape 31"/>
+          <p:cNvSpPr/>
+          <p:nvPr/>
+        </p:nvSpPr>
+        <p:spPr>
+          <a:xfrm>
+            <a:off x="9921240" y="4983480"/>
+            <a:ext cx="1554480" cy="502920"/>
+          </a:xfrm>
+          <a:prstGeom prst="rect">
+            <a:avLst/>
+          </a:prstGeom>
+          <a:solidFill>
+            <a:srgbClr val="FBFFF4"/>
+          </a:solidFill>
+          <a:ln w="12700">
+            <a:solidFill>
+              <a:srgbClr val="B8D98A"/>
+            </a:solidFill>
+            <a:prstDash val="solid"/>
+          </a:ln>
+        </p:spPr>
+      </p:sp>
+      <p:sp>
+        <p:nvSpPr>
+          <p:cNvPr id="35" name="Text 32"/>
+          <p:cNvSpPr txBox="1"/>
+          <p:nvPr/>
+        </p:nvSpPr>
+        <p:spPr>
+          <a:xfrm>
+            <a:off x="10012680" y="4983480"/>
+            <a:ext cx="1371600" cy="502920"/>
+          </a:xfrm>
+          <a:prstGeom prst="rect">
+            <a:avLst/>
+          </a:prstGeom>
+          <a:noFill/>
+          <a:ln/>
+        </p:spPr>
+        <p:txBody>
+          <a:bodyPr wrap="square" lIns="0" tIns="0" rIns="0" bIns="0" rtlCol="0" anchor="ctr"/>
+          <a:lstStyle/>
+          <a:p>
+            <a:pPr algn="l" indent="0" marL="0">
+              <a:buNone/>
+            </a:pPr>
+            <a:r>
+              <a:rPr lang="en-US" sz="1400" dirty="0">
+                <a:solidFill>
+                  <a:srgbClr val="0E1F0C"/>
+                </a:solidFill>
+                <a:latin typeface="Poppins" pitchFamily="34" charset="0"/>
+                <a:ea typeface="Poppins" pitchFamily="34" charset="-122"/>
+                <a:cs typeface="Poppins" pitchFamily="34" charset="-120"/>
+              </a:rPr>
+              <a:t>…</a:t>
+            </a:r>
+            <a:endParaRPr lang="en-US" sz="1400" dirty="0"/>
+          </a:p>
+        </p:txBody>
+      </p:sp>
+      <p:sp>
+        <p:nvSpPr>
+          <p:cNvPr id="36" name="Shape 33"/>
+          <p:cNvSpPr/>
+          <p:nvPr/>
+        </p:nvSpPr>
+        <p:spPr>
+          <a:xfrm>
+            <a:off x="6629400" y="5486400"/>
+            <a:ext cx="1737360" cy="502920"/>
+          </a:xfrm>
+          <a:prstGeom prst="rect">
+            <a:avLst/>
+          </a:prstGeom>
+          <a:solidFill>
+            <a:srgbClr val="FBFFF4"/>
+          </a:solidFill>
+          <a:ln w="12700">
+            <a:solidFill>
+              <a:srgbClr val="B8D98A"/>
+            </a:solidFill>
+            <a:prstDash val="solid"/>
+          </a:ln>
+        </p:spPr>
+      </p:sp>
+      <p:sp>
+        <p:nvSpPr>
+          <p:cNvPr id="37" name="Text 34"/>
+          <p:cNvSpPr txBox="1"/>
+          <p:nvPr/>
+        </p:nvSpPr>
+        <p:spPr>
+          <a:xfrm>
+            <a:off x="6720840" y="5486400"/>
+            <a:ext cx="1554480" cy="502920"/>
+          </a:xfrm>
+          <a:prstGeom prst="rect">
+            <a:avLst/>
+          </a:prstGeom>
+          <a:noFill/>
+          <a:ln/>
+        </p:spPr>
+        <p:txBody>
+          <a:bodyPr wrap="square" lIns="0" tIns="0" rIns="0" bIns="0" rtlCol="0" anchor="ctr"/>
+          <a:lstStyle/>
+          <a:p>
+            <a:pPr algn="l" indent="0" marL="0">
+              <a:buNone/>
+            </a:pPr>
+            <a:r>
+              <a:rPr lang="en-US" sz="1400" dirty="0">
+                <a:solidFill>
+                  <a:srgbClr val="0E1F0C"/>
+                </a:solidFill>
+                <a:latin typeface="Poppins" pitchFamily="34" charset="0"/>
+                <a:ea typeface="Poppins" pitchFamily="34" charset="-122"/>
+                <a:cs typeface="Poppins" pitchFamily="34" charset="-120"/>
+              </a:rPr>
+              <a:t>2</a:t>
+            </a:r>
+            <a:endParaRPr lang="en-US" sz="1400" dirty="0"/>
+          </a:p>
+        </p:txBody>
+      </p:sp>
+      <p:sp>
+        <p:nvSpPr>
+          <p:cNvPr id="38" name="Shape 35"/>
+          <p:cNvSpPr/>
+          <p:nvPr/>
+        </p:nvSpPr>
+        <p:spPr>
+          <a:xfrm>
+            <a:off x="8366760" y="5486400"/>
+            <a:ext cx="1554480" cy="502920"/>
+          </a:xfrm>
+          <a:prstGeom prst="rect">
+            <a:avLst/>
+          </a:prstGeom>
+          <a:solidFill>
+            <a:srgbClr val="FBFFF4"/>
+          </a:solidFill>
+          <a:ln w="12700">
+            <a:solidFill>
+              <a:srgbClr val="B8D98A"/>
+            </a:solidFill>
+            <a:prstDash val="solid"/>
+          </a:ln>
+        </p:spPr>
+      </p:sp>
+      <p:sp>
+        <p:nvSpPr>
+          <p:cNvPr id="39" name="Text 36"/>
+          <p:cNvSpPr txBox="1"/>
+          <p:nvPr/>
+        </p:nvSpPr>
+        <p:spPr>
+          <a:xfrm>
+            <a:off x="8458200" y="5486400"/>
+            <a:ext cx="1371600" cy="502920"/>
+          </a:xfrm>
+          <a:prstGeom prst="rect">
+            <a:avLst/>
+          </a:prstGeom>
+          <a:noFill/>
+          <a:ln/>
+        </p:spPr>
+        <p:txBody>
+          <a:bodyPr wrap="square" lIns="0" tIns="0" rIns="0" bIns="0" rtlCol="0" anchor="ctr"/>
+          <a:lstStyle/>
+          <a:p>
+            <a:pPr algn="l" indent="0" marL="0">
+              <a:buNone/>
+            </a:pPr>
+            <a:r>
+              <a:rPr lang="en-US" sz="1400" dirty="0">
+                <a:solidFill>
+                  <a:srgbClr val="0E1F0C"/>
+                </a:solidFill>
+                <a:latin typeface="Poppins" pitchFamily="34" charset="0"/>
+                <a:ea typeface="Poppins" pitchFamily="34" charset="-122"/>
+                <a:cs typeface="Poppins" pitchFamily="34" charset="-120"/>
+              </a:rPr>
+              <a:t>…</a:t>
+            </a:r>
+            <a:endParaRPr lang="en-US" sz="1400" dirty="0"/>
+          </a:p>
+        </p:txBody>
+      </p:sp>
+      <p:sp>
+        <p:nvSpPr>
+          <p:cNvPr id="40" name="Shape 37"/>
+          <p:cNvSpPr/>
+          <p:nvPr/>
+        </p:nvSpPr>
+        <p:spPr>
+          <a:xfrm>
+            <a:off x="9921240" y="5486400"/>
+            <a:ext cx="1554480" cy="502920"/>
+          </a:xfrm>
+          <a:prstGeom prst="rect">
+            <a:avLst/>
+          </a:prstGeom>
+          <a:solidFill>
+            <a:srgbClr val="FBFFF4"/>
+          </a:solidFill>
+          <a:ln w="12700">
+            <a:solidFill>
+              <a:srgbClr val="B8D98A"/>
+            </a:solidFill>
+            <a:prstDash val="solid"/>
+          </a:ln>
+        </p:spPr>
+      </p:sp>
+      <p:sp>
+        <p:nvSpPr>
+          <p:cNvPr id="41" name="Text 38"/>
+          <p:cNvSpPr txBox="1"/>
+          <p:nvPr/>
+        </p:nvSpPr>
+        <p:spPr>
+          <a:xfrm>
+            <a:off x="10012680" y="5486400"/>
+            <a:ext cx="1371600" cy="502920"/>
+          </a:xfrm>
+          <a:prstGeom prst="rect">
+            <a:avLst/>
+          </a:prstGeom>
+          <a:noFill/>
+          <a:ln/>
+        </p:spPr>
+        <p:txBody>
+          <a:bodyPr wrap="square" lIns="0" tIns="0" rIns="0" bIns="0" rtlCol="0" anchor="ctr"/>
+          <a:lstStyle/>
+          <a:p>
+            <a:pPr algn="l" indent="0" marL="0">
+              <a:buNone/>
+            </a:pPr>
+            <a:r>
+              <a:rPr lang="en-US" sz="1400" dirty="0">
+                <a:solidFill>
+                  <a:srgbClr val="0E1F0C"/>
+                </a:solidFill>
+                <a:latin typeface="Poppins" pitchFamily="34" charset="0"/>
+                <a:ea typeface="Poppins" pitchFamily="34" charset="-122"/>
+                <a:cs typeface="Poppins" pitchFamily="34" charset="-120"/>
+              </a:rPr>
+              <a:t>…</a:t>
+            </a:r>
+            <a:endParaRPr lang="en-US" sz="1400" dirty="0"/>
+          </a:p>
+        </p:txBody>
+      </p:sp>
+      <p:sp>
+        <p:nvSpPr>
+          <p:cNvPr id="42" name="Shape 39"/>
+          <p:cNvSpPr/>
+          <p:nvPr/>
+        </p:nvSpPr>
+        <p:spPr>
+          <a:xfrm>
+            <a:off x="8229600" y="3977640"/>
+            <a:ext cx="2377440" cy="411480"/>
+          </a:xfrm>
+          <a:prstGeom prst="roundRect">
+            <a:avLst>
+              <a:gd name="adj" fmla="val 17778"/>
+            </a:avLst>
+          </a:prstGeom>
+          <a:solidFill>
+            <a:srgbClr val="12301A"/>
+          </a:solidFill>
+          <a:ln w="12700">
+            <a:solidFill>
+              <a:srgbClr val="12301A"/>
+            </a:solidFill>
+            <a:prstDash val="solid"/>
+          </a:ln>
+        </p:spPr>
+      </p:sp>
+      <p:sp>
+        <p:nvSpPr>
+          <p:cNvPr id="43" name="Text 40"/>
+          <p:cNvSpPr txBox="1"/>
+          <p:nvPr/>
+        </p:nvSpPr>
+        <p:spPr>
+          <a:xfrm>
+            <a:off x="8229600" y="3977640"/>
+            <a:ext cx="2377440" cy="411480"/>
+          </a:xfrm>
+          <a:prstGeom prst="rect">
+            <a:avLst/>
+          </a:prstGeom>
+          <a:noFill/>
+          <a:ln/>
+        </p:spPr>
+        <p:txBody>
+          <a:bodyPr wrap="square" lIns="0" tIns="0" rIns="0" bIns="0" rtlCol="0" anchor="ctr"/>
+          <a:lstStyle/>
+          <a:p>
+            <a:pPr algn="ctr" indent="0" marL="0">
+              <a:buNone/>
+            </a:pPr>
+            <a:r>
+              <a:rPr lang="en-US" sz="1400" b="1" dirty="0">
+                <a:solidFill>
+                  <a:srgbClr val="B1FF37"/>
+                </a:solidFill>
+                <a:latin typeface="Poppins" pitchFamily="34" charset="0"/>
+                <a:ea typeface="Poppins" pitchFamily="34" charset="-122"/>
+                <a:cs typeface="Poppins" pitchFamily="34" charset="-120"/>
+              </a:rPr>
+              <a:t>Neue Tabelle: Bücher</a:t>
+            </a:r>
+            <a:endParaRPr lang="en-US" sz="1400" dirty="0"/>
           </a:p>
         </p:txBody>
       </p:sp>

</xml_diff>